<commit_message>
docs: refine Claude Code presentation for engineering audience
- Rewrite speaker notes to target software engineers only (remove non-tech framing on slides 1, 3, 10, 12, 14)
- Fix Shift+Tab label on slide 13 ("Toggle plan mode" → "Cycle modes"; actual behavior cycles Normal → Auto-Accept → Plan)
- Add /memory to slide 13 notes for consistency with Auto memory mention on slide 5
- Add Android mobile surface to slide 11 notes (launched March 2026)

https://claude.ai/code/session_01Kgzc6V4nJffvzBdXGUme9z
</commit_message>
<xml_diff>
--- a/Claude_Code.pptx
+++ b/Claude_Code.pptx
@@ -516,7 +516,7 @@
             <a:r>
               <a:rPr lang="en-US" dirty="0"/>
               <a:t>Deschiderea: ăsta e un brief intern, nu o prezentare de vânzare. Acoperim ce e Claude Code, vocabularul de reținut (MCP, Skills, Subagents), ce face bine și comenzile pe care merită să le ții minte.
-Audiența e mixtă — engineeri ȘI non-engineeri (PM-i, design). Scopul e înțelegere comună, nu evangelizare. La final, toată lumea să știe ce înseamnă când un coleg zice „am folosit Claude Code să fac refactor la auth layer".
+Audiența: engineeri. Scopul e înțelegere comună a vocabularului și capabilităților, nu evangelizare. La final, toată lumea să aibă referințe clare când apare Claude Code într-o discuție tehnică.
 Durata: ~15-20 min cu discuție. Pauze pentru întrebări după slide-urile de concepte (MCP, Skills, Subagents) — alea sunt cele mai dense.</a:t>
             </a:r>
             <a:endParaRPr lang="en-US" dirty="0"/>
@@ -611,7 +611,7 @@
 • Etapa 3 (Act) — unde se duce majoritatea timpului. Depinde de mărimea task-ului.
 • Etapa 4 (Verify) — automată când există teste care rulează rapid.
 Dacă planul din etapa 2 nu se aliniază cu ce ai vrut, poți întrerupe cu Ctrl+C și reformula. Nu e necesar să lași bucla să se execute dacă direcția e greșită — devine parte din flow-ul iterativ.
-Pentru audiența non-tech: ce trebuie reținut nu sunt detaliile tehnice. E că Claude afișează ce face la fiecare etapă. Procesul e vizibil și întreruptibil — nu e o cutie neagră.
+Procesul e observabil step-by-step — util pentru debugging când ceva iese prost. Dacă verify-ul eșuează, vezi exact la ce etapă și cu ce context a luat decizia greșită.
 Exemplu similar poate fi folosit ca demo live — mic task pe un proiect local.</a:t>
             </a:r>
             <a:endParaRPr lang="en-US" dirty="0"/>
@@ -707,7 +707,7 @@
 • JetBrains — plugin cu funcționalitate similară, pentru IntelliJ, PyCharm, WebStorm.
 • Desktop app — versiune nativă pentru macOS/Windows.
 • Web (claude.ai/code) — rulează în cloud, fără setup local. Util pentru task-uri lungi care pot rula în background.
-• iOS — permite începerea unui task de pe telefon, cu rezultatele accesibile ulterior.
+• Mobile — apps native iOS (din oct 2025) și Android (din martie 2026). Permite începerea unui task de pe telefon, cu rezultatele accesibile ulterior.
 GitHub Actions e singurul surface non-interactiv — se invocă prin tag-uirea @claude în PR-uri sau issue-uri, util pentru automatizare CI.
 Toate surface-urile împart același cont și configurare — aceleași skills, aceleași MCP servers, aceeași ierarhie CLAUDE.md.</a:t>
             </a:r>
@@ -803,8 +803,7 @@
 1. Understand code — read-only, fără modificări. Util pentru familiarizare cu un proiect necunoscut.
 2. Fix a bug — scope focalizat, verificabil prin teste.
 3. Build a feature — modificări multiple, necesită review atent al diff-ului.
-Notă de prompting: specificitatea constraint-urilor influențează calitatea rezultatului. „Adaugă paginare" e vag. „Adaugă paginare cursor-based la /users cu page size 20, urmând pattern-ul de error-handling din /posts" e specific și produce rezultate mai bine aliniate cu proiectul.
-Pentru cineva care nu știe vocabularul tehnic: descrierea problemei în limba normală e suficientă. Claude pune întrebări de clarificare când are nevoie.</a:t>
+Notă de prompting: specificitatea constraint-urilor influențează calitatea rezultatului. „Adaugă paginare" e vag. „Adaugă paginare cursor-based la /users cu page size 20, urmând pattern-ul de error-handling din /posts" e specific și produce rezultate mai bine aliniate cu proiectul.</a:t>
             </a:r>
             <a:endParaRPr lang="en-US" dirty="0"/>
           </a:p>
@@ -901,6 +900,7 @@
 • `claude -p "..."` — mod non-interactiv. Rulează un prompt, afișează răspunsul, iese. Folosit în shell scripts și pipeline-uri CI.
 • `--permission-mode acceptEdits` — auto-aprobă modificările de fișiere. Util după ce workflow-ul e familiar.
 • `@` — referință la un fișier în prompt, ex: „explică @src/auth.ts".
+• `/memory` — vizualizează și editează memoria auto-salvată între sesiuni (v2.1.59+).
 Notă: Claude Code funcționează fără să memorezi aceste comenzi. Sunt shortcut-uri pentru folosire frecventă.</a:t>
             </a:r>
             <a:endParaRPr lang="en-US" dirty="0"/>
@@ -990,13 +990,9 @@
             <a:r>
               <a:rPr lang="en-US" dirty="0"/>
               <a:t>Pași concreți de încheiere:
-Pentru engineeri:
 1. Instalarea Claude Code (instrucțiuni pe docs.claude.com).
 2. Scrierea unui CLAUDE.md pentru proiectul principal — convenții, comenzi uzuale, pattern-uri de urmărit.
 3. Încercarea unui task concret: explicarea unui modul, fix la un bug, sau adăugarea unui test.
-Pentru PM-i / design:
-1. Accesarea claude.ai/code în browser — fără instalare.
-2. Încercarea pe un task specific muncii: sumar al unui repo, review pe un PR, draft pentru un spec tehnic.
 Pentru echipă (discuție ulterioară):
 1. Identificarea MCP servers care s-ar potrivi cu workflow-ul nostru (ex: GitHub, Jira).
 2. Discutarea experienței pe canalul de echipă.
@@ -1183,7 +1179,6 @@
               <a:rPr lang="en-US" dirty="0"/>
               <a:t>„Agentic" înseamnă un sistem cu un scop, acces la tool-uri, și autonomia să continue până termină task-ul sau cere input.
 Cele patru etape (Understand → Plan → Act → Verify) sunt un model mental simplificat, nu o taxonomie oficială din docs. Pentru task-uri complexe, bucla se execută de mai multe ori — Claude încearcă ceva, realizează că-i lipsește context, mai citește fișiere, re-planifică, acționează din nou.
-Pentru audiența non-tech: AI-ul tradițional răspunde la întrebări. AI-ul agentic execută sarcini — primește un obiectiv, decide singur pașii, folosește tool-uri (citire fișiere, rulare comenzi), verifică rezultatul.
 Claude cere permisiune înainte de acțiuni semnificative (rulare comenzi, editări de fișiere). Autonomia e limitată prin permisiuni — tu rămâi la butoane.</a:t>
             </a:r>
             <a:endParaRPr lang="en-US" dirty="0"/>
@@ -6117,7 +6112,7 @@
                 <a:ea typeface="Calibri" pitchFamily="34" charset="-122"/>
                 <a:cs typeface="Calibri" pitchFamily="34" charset="-120"/>
               </a:rPr>
-              <a:t>Toggle plan mode</a:t>
+              <a:t>Cycle modes</a:t>
             </a:r>
             <a:endParaRPr lang="en-US" sz="1050" dirty="0"/>
           </a:p>

</xml_diff>

<commit_message>
docs: tighten presentation tone and add limitations slide
Six edits to make the deck more useful for engineers and less marketing-flavored:

- Slide 2: "understands your codebase" → "reads and reasons over it"
  ("understands" is too anthropomorphic for a technical audience)
- Slide 8: "a reviewer can't run bash" → "a reviewer doesn't need Bash"
  (it's a config choice, not a property of subagents)
- Slide 9: rewrite capability descriptions to state what happens, not how
  great it is (less "takes off your plate", more "runs the suite")
- Slide 12: replace vague prompt templates with specific ones that model
  the specificity advice in the notes (file refs, error strings, patterns)
- Slide 13: drop the invented "80% of day-to-day" claim
- New slide 14 (LIMITATIONS): four common failure modes — dropped
  context, plausible hallucinations, hidden state, and the need to own
  the diff. Moves END to slide 15.

https://claude.ai/code/session_01Kgzc6V4nJffvzBdXGUme9z
</commit_message>
<xml_diff>
--- a/Claude_Code.pptx
+++ b/Claude_Code.pptx
@@ -18,6 +18,7 @@
     <p:sldId id="266" r:id="rId12"/>
     <p:sldId id="267" r:id="rId13"/>
     <p:sldId id="268" r:id="rId14"/>
+    <p:sldId id="270" r:id="rId21"/>
     <p:sldId id="269" r:id="rId15"/>
   </p:sldIdLst>
   <p:notesMasterIdLst>
@@ -1022,6 +1023,99 @@
             <a:fld id="{F7021451-1387-4CA6-816F-3879F97B5CBC}" type="slidenum">
               <a:rPr lang="en-US"/>
               <a:t>14</a:t>
+            </a:fld>
+            <a:endParaRPr lang="en-US"/>
+          </a:p>
+        </p:txBody>
+      </p:sp>
+    </p:spTree>
+    <p:extLst>
+      <p:ext uri="{BB962C8B-B14F-4D97-AF65-F5344CB8AC3E}">
+        <p14:creationId xmlns:p14="http://schemas.microsoft.com/office/powerpoint/2010/main" val="1024086991"/>
+      </p:ext>
+    </p:extLst>
+  </p:cSld>
+  <p:clrMapOvr>
+    <a:masterClrMapping/>
+  </p:clrMapOvr>
+</p:notes>
+</file>
+
+<file path=ppt/notesSlides/notesSlide15.xml><?xml version="1.0" encoding="utf-8"?>
+<p:notes xmlns:a="http://schemas.openxmlformats.org/drawingml/2006/main" xmlns:r="http://schemas.openxmlformats.org/officeDocument/2006/relationships" xmlns:p="http://schemas.openxmlformats.org/presentationml/2006/main">
+  <p:cSld>
+    <p:spTree>
+      <p:nvGrpSpPr>
+        <p:cNvPr id="1" name=""/>
+        <p:cNvGrpSpPr/>
+        <p:nvPr/>
+      </p:nvGrpSpPr>
+      <p:grpSpPr>
+        <a:xfrm>
+          <a:off x="0" y="0"/>
+          <a:ext cx="0" cy="0"/>
+          <a:chOff x="0" y="0"/>
+          <a:chExt cx="0" cy="0"/>
+        </a:xfrm>
+      </p:grpSpPr>
+      <p:sp>
+        <p:nvSpPr>
+          <p:cNvPr id="2" name="Slide Image Placeholder 1"/>
+          <p:cNvSpPr>
+            <a:spLocks noGrp="1" noRot="1" noChangeAspect="1"/>
+          </p:cNvSpPr>
+          <p:nvPr>
+            <p:ph type="sldImg"/>
+          </p:nvPr>
+        </p:nvSpPr>
+        <p:spPr/>
+      </p:sp>
+      <p:sp>
+        <p:nvSpPr>
+          <p:cNvPr id="3" name="Notes Placeholder 2"/>
+          <p:cNvSpPr>
+            <a:spLocks noGrp="1"/>
+          </p:cNvSpPr>
+          <p:nvPr>
+            <p:ph type="body" idx="1"/>
+          </p:nvPr>
+        </p:nvSpPr>
+        <p:spPr/>
+        <p:txBody>
+          <a:bodyPr/>
+          <a:lstStyle/>
+          <a:p>
+            <a:r>
+              <a:rPr lang="en-US" dirty="0"/>
+              <a:t>Acest slide e pentru onestitate și pentru a pregăti audiența să recunoască aceste tipare în practică. Niciuna dintre limitări nu e blocantă; toate sunt gestionabile cu review atent.
+• Context dropped: apare la sesiuni lungi, fișiere mari, sau zeci de tool calls. Claude poate să uite o decizie luată la începutul sesiunii. /clear resetează, /compact rezumă, @ aduce conținut la zi în context.
+• Plausible but wrong: cel mai insidios tip de eșec — codul compilează, testele trec, sintaxa e ok, dar comportamentul e greșit. Apare când API-ul real diferă de ce Claude presupune. Verifică cu documentația oficială sau rulări concrete, nu doar cu lint.
+• Hidden state: orice nu e în cod e invizibil pentru Claude — variabile de mediu, feature flags, convenții ne-scrise, comportamentul unui API extern. Dacă task-ul depinde de așa ceva, spune-i explicit: „backend-ul așteaptă camelCase” sau „feature flag X e on în prod”.
+• Own the diff: regula de bază. Claude e un contributor, nu un owner. Citește fiecare hunk ca și cum ar veni de la un coleg nou: nu presupune că înțelege convențiile proiectului la fel de bine ca tine. Green CI nu înseamnă corect.
+Mențiune: nu sunt toate limitările — doar cele mai des întâlnite în munca zilnică. Altele (matematică, rază de acțiune, latență) sunt contextuale și merită discutate separat.</a:t>
+            </a:r>
+            <a:endParaRPr lang="en-US" dirty="0"/>
+          </a:p>
+        </p:txBody>
+      </p:sp>
+      <p:sp>
+        <p:nvSpPr>
+          <p:cNvPr id="4" name="Slide Number Placeholder 3"/>
+          <p:cNvSpPr>
+            <a:spLocks noGrp="1"/>
+          </p:cNvSpPr>
+          <p:nvPr>
+            <p:ph type="sldNum" sz="quarter" idx="10"/>
+          </p:nvPr>
+        </p:nvSpPr>
+        <p:spPr/>
+        <p:txBody>
+          <a:bodyPr/>
+          <a:lstStyle/>
+          <a:p>
+            <a:fld id="{F7021451-1387-4CA6-816F-3879F97B5CBC}" type="slidenum">
+              <a:rPr lang="en-US"/>
+              <a:t>4</a:t>
             </a:fld>
             <a:endParaRPr lang="en-US"/>
           </a:p>
@@ -4721,7 +4815,7 @@
                 <a:ea typeface="Consolas" pitchFamily="34" charset="-122"/>
                 <a:cs typeface="Consolas" pitchFamily="34" charset="-120"/>
               </a:rPr>
-              <a:t>"Build a new API endpoint that returns user profiles and write the tests for it."</a:t>
+              <a:t>"Add GET /users/:id returning name, email, created_at. Match the error-handling in routes/posts.js. Include tests."</a:t>
             </a:r>
             <a:endParaRPr lang="en-US" sz="1100" dirty="0"/>
           </a:p>
@@ -4934,7 +5028,7 @@
                 <a:ea typeface="Consolas" pitchFamily="34" charset="-122"/>
                 <a:cs typeface="Consolas" pitchFamily="34" charset="-120"/>
               </a:rPr>
-              <a:t>"I'm getting this error on startup. Find the cause in the codebase and fix it."</a:t>
+              <a:t>"Startup throws 'Cannot read property X of undefined' from services/auth.ts:42. Find the cause and fix it."</a:t>
             </a:r>
             <a:endParaRPr lang="en-US" sz="1100" dirty="0"/>
           </a:p>
@@ -5147,7 +5241,7 @@
                 <a:ea typeface="Consolas" pitchFamily="34" charset="-122"/>
                 <a:cs typeface="Consolas" pitchFamily="34" charset="-120"/>
               </a:rPr>
-              <a:t>"Walk me through how our authentication system works. Show the important files."</a:t>
+              <a:t>"Walk me through auth end-to-end. Start at the login endpoint; call out the token validation path."</a:t>
             </a:r>
             <a:endParaRPr lang="en-US" sz="1100" dirty="0"/>
           </a:p>
@@ -6988,7 +7082,7 @@
                 <a:ea typeface="Calibri" pitchFamily="34" charset="-122"/>
                 <a:cs typeface="Calibri" pitchFamily="34" charset="-120"/>
               </a:rPr>
-              <a:t>Start with /clear and Shift+Tab — those two cover 80% of day-to-day session control.</a:t>
+              <a:t>Start with /clear and Shift+Tab — the two you'll use most often.</a:t>
             </a:r>
             <a:endParaRPr lang="en-US" sz="1000" dirty="0"/>
           </a:p>
@@ -7458,6 +7552,986 @@
                 <a:ea typeface="Calibri" pitchFamily="34" charset="-122"/>
                 <a:cs typeface="Calibri" pitchFamily="34" charset="-120"/>
               </a:rPr>
+              <a:t>15</a:t>
+            </a:r>
+            <a:endParaRPr lang="en-US" sz="1000" dirty="0"/>
+          </a:p>
+        </p:txBody>
+      </p:sp>
+    </p:spTree>
+  </p:cSld>
+  <p:clrMapOvr>
+    <a:masterClrMapping/>
+  </p:clrMapOvr>
+</p:sld>
+</file>
+
+<file path=ppt/slides/slide15.xml><?xml version="1.0" encoding="utf-8"?>
+<p:sld xmlns:a="http://schemas.openxmlformats.org/drawingml/2006/main" xmlns:r="http://schemas.openxmlformats.org/officeDocument/2006/relationships" xmlns:p="http://schemas.openxmlformats.org/presentationml/2006/main">
+  <p:cSld name="Slide 15">
+    <p:bg>
+      <p:bgPr>
+        <a:solidFill>
+          <a:srgbClr val="F7F5F0"/>
+        </a:solidFill>
+      </p:bgPr>
+    </p:bg>
+    <p:spTree>
+      <p:nvGrpSpPr>
+        <p:cNvPr id="1" name=""/>
+        <p:cNvGrpSpPr/>
+        <p:nvPr/>
+      </p:nvGrpSpPr>
+      <p:grpSpPr>
+        <a:xfrm>
+          <a:off x="0" y="0"/>
+          <a:ext cx="0" cy="0"/>
+          <a:chOff x="0" y="0"/>
+          <a:chExt cx="0" cy="0"/>
+        </a:xfrm>
+      </p:grpSpPr>
+      <p:sp>
+        <p:nvSpPr>
+          <p:cNvPr id="2" name="Text 0"/>
+          <p:cNvSpPr/>
+          <p:nvPr/>
+        </p:nvSpPr>
+        <p:spPr>
+          <a:xfrm>
+            <a:off x="502920" y="411480"/>
+            <a:ext cx="6400800" cy="274320"/>
+          </a:xfrm>
+          <a:prstGeom prst="rect">
+            <a:avLst/>
+          </a:prstGeom>
+          <a:noFill/>
+          <a:ln/>
+        </p:spPr>
+        <p:txBody>
+          <a:bodyPr wrap="square" lIns="0" tIns="0" rIns="0" bIns="0" rtlCol="0" anchor="ctr"/>
+          <a:lstStyle/>
+          <a:p>
+            <a:pPr indent="0" marL="0">
+              <a:buNone/>
+            </a:pPr>
+            <a:r>
+              <a:rPr lang="en-US" sz="1000" b="1" spc="400" kern="0" dirty="0">
+                <a:solidFill>
+                  <a:srgbClr val="CC785C"/>
+                </a:solidFill>
+                <a:latin typeface="Calibri" pitchFamily="34" charset="0"/>
+                <a:ea typeface="Calibri" pitchFamily="34" charset="-122"/>
+                <a:cs typeface="Calibri" pitchFamily="34" charset="-120"/>
+              </a:rPr>
+              <a:t>13  —  LIMITATIONS</a:t>
+            </a:r>
+            <a:endParaRPr lang="en-US" sz="1000" dirty="0"/>
+          </a:p>
+        </p:txBody>
+      </p:sp>
+      <p:sp>
+        <p:nvSpPr>
+          <p:cNvPr id="3" name="Text 1"/>
+          <p:cNvSpPr/>
+          <p:nvPr/>
+        </p:nvSpPr>
+        <p:spPr>
+          <a:xfrm>
+            <a:off x="502920" y="731520"/>
+            <a:ext cx="8229600" cy="685800"/>
+          </a:xfrm>
+          <a:prstGeom prst="rect">
+            <a:avLst/>
+          </a:prstGeom>
+          <a:noFill/>
+          <a:ln/>
+        </p:spPr>
+        <p:txBody>
+          <a:bodyPr wrap="square" lIns="0" tIns="0" rIns="0" bIns="0" rtlCol="0" anchor="ctr"/>
+          <a:lstStyle/>
+          <a:p>
+            <a:pPr indent="0" marL="0">
+              <a:buNone/>
+            </a:pPr>
+            <a:r>
+              <a:rPr lang="en-US" sz="3600" b="1" dirty="0">
+                <a:solidFill>
+                  <a:srgbClr val="1A1B1F"/>
+                </a:solidFill>
+                <a:latin typeface="Georgia" pitchFamily="34" charset="0"/>
+                <a:ea typeface="Georgia" pitchFamily="34" charset="-122"/>
+                <a:cs typeface="Georgia" pitchFamily="34" charset="-120"/>
+              </a:rPr>
+              <a:t>Where it falls short</a:t>
+            </a:r>
+            <a:endParaRPr lang="en-US" sz="3600" dirty="0"/>
+          </a:p>
+        </p:txBody>
+      </p:sp>
+      <p:sp>
+        <p:nvSpPr>
+          <p:cNvPr id="4" name="Text 2"/>
+          <p:cNvSpPr/>
+          <p:nvPr/>
+        </p:nvSpPr>
+        <p:spPr>
+          <a:xfrm>
+            <a:off x="502920" y="1417320"/>
+            <a:ext cx="8229600" cy="365760"/>
+          </a:xfrm>
+          <a:prstGeom prst="rect">
+            <a:avLst/>
+          </a:prstGeom>
+          <a:noFill/>
+          <a:ln/>
+        </p:spPr>
+        <p:txBody>
+          <a:bodyPr wrap="square" lIns="0" tIns="0" rIns="0" bIns="0" rtlCol="0" anchor="ctr"/>
+          <a:lstStyle/>
+          <a:p>
+            <a:pPr indent="0" marL="0">
+              <a:buNone/>
+            </a:pPr>
+            <a:r>
+              <a:rPr lang="en-US" sz="1300" i="1" dirty="0">
+                <a:solidFill>
+                  <a:srgbClr val="6B6A66"/>
+                </a:solidFill>
+                <a:latin typeface="Calibri" pitchFamily="34" charset="0"/>
+                <a:ea typeface="Calibri" pitchFamily="34" charset="-122"/>
+                <a:cs typeface="Calibri" pitchFamily="34" charset="-120"/>
+              </a:rPr>
+              <a:t>Knowing the failure modes makes you faster at catching them. Always read the diff.</a:t>
+            </a:r>
+            <a:endParaRPr lang="en-US" sz="1300" dirty="0"/>
+          </a:p>
+        </p:txBody>
+      </p:sp>
+      <p:sp>
+        <p:nvSpPr>
+          <p:cNvPr id="5" name="Shape 3"/>
+          <p:cNvSpPr/>
+          <p:nvPr/>
+        </p:nvSpPr>
+        <p:spPr>
+          <a:xfrm>
+            <a:off x="502920" y="1965960"/>
+            <a:ext cx="4023360" cy="1371600"/>
+          </a:xfrm>
+          <a:prstGeom prst="rect">
+            <a:avLst/>
+          </a:prstGeom>
+          <a:solidFill>
+            <a:srgbClr val="FFFFFF"/>
+          </a:solidFill>
+          <a:ln w="9525">
+            <a:solidFill>
+              <a:srgbClr val="E3DFD7"/>
+            </a:solidFill>
+            <a:prstDash val="solid"/>
+          </a:ln>
+          <a:effectLst>
+            <a:outerShdw sx="100000" sy="100000" kx="0" ky="0" algn="bl" rotWithShape="0" blurRad="127000" dist="25400" dir="5400000">
+              <a:srgbClr val="000000">
+                <a:alpha val="8000"/>
+              </a:srgbClr>
+            </a:outerShdw>
+          </a:effectLst>
+        </p:spPr>
+      </p:sp>
+      <p:sp>
+        <p:nvSpPr>
+          <p:cNvPr id="6" name="Shape 4"/>
+          <p:cNvSpPr/>
+          <p:nvPr/>
+        </p:nvSpPr>
+        <p:spPr>
+          <a:xfrm>
+            <a:off x="502920" y="1965960"/>
+            <a:ext cx="64008" cy="1371600"/>
+          </a:xfrm>
+          <a:prstGeom prst="rect">
+            <a:avLst/>
+          </a:prstGeom>
+          <a:solidFill>
+            <a:srgbClr val="CC785C"/>
+          </a:solidFill>
+          <a:ln w="12700">
+            <a:solidFill>
+              <a:srgbClr val="CC785C"/>
+            </a:solidFill>
+            <a:prstDash val="solid"/>
+          </a:ln>
+        </p:spPr>
+      </p:sp>
+      <p:pic>
+        <p:nvPicPr>
+          <p:cNvPr id="7" name="Image 0" descr="preencoded.png">    </p:cNvPr>
+          <p:cNvPicPr>
+            <a:picLocks noChangeAspect="1"/>
+          </p:cNvPicPr>
+          <p:nvPr/>
+        </p:nvPicPr>
+        <p:blipFill>
+          <a:blip r:embed="rId1"/>
+          <a:stretch>
+            <a:fillRect/>
+          </a:stretch>
+        </p:blipFill>
+        <p:spPr>
+          <a:xfrm>
+            <a:off x="758952" y="2194560"/>
+            <a:ext cx="320040" cy="320040"/>
+          </a:xfrm>
+          <a:prstGeom prst="rect">
+            <a:avLst/>
+          </a:prstGeom>
+        </p:spPr>
+      </p:pic>
+      <p:sp>
+        <p:nvSpPr>
+          <p:cNvPr id="8" name="Text 5"/>
+          <p:cNvSpPr/>
+          <p:nvPr/>
+        </p:nvSpPr>
+        <p:spPr>
+          <a:xfrm>
+            <a:off x="1188720" y="2130552"/>
+            <a:ext cx="3200400" cy="320040"/>
+          </a:xfrm>
+          <a:prstGeom prst="rect">
+            <a:avLst/>
+          </a:prstGeom>
+          <a:noFill/>
+          <a:ln/>
+        </p:spPr>
+        <p:txBody>
+          <a:bodyPr wrap="square" lIns="0" tIns="0" rIns="0" bIns="0" rtlCol="0" anchor="ctr"/>
+          <a:lstStyle/>
+          <a:p>
+            <a:pPr indent="0" marL="0">
+              <a:buNone/>
+            </a:pPr>
+            <a:r>
+              <a:rPr lang="en-US" sz="1800" b="1" dirty="0">
+                <a:solidFill>
+                  <a:srgbClr val="1A1B1F"/>
+                </a:solidFill>
+                <a:latin typeface="Georgia" pitchFamily="34" charset="0"/>
+                <a:ea typeface="Georgia" pitchFamily="34" charset="-122"/>
+                <a:cs typeface="Georgia" pitchFamily="34" charset="-120"/>
+              </a:rPr>
+              <a:t>Context</a:t>
+            </a:r>
+            <a:endParaRPr lang="en-US" sz="1800" dirty="0"/>
+          </a:p>
+        </p:txBody>
+      </p:sp>
+      <p:sp>
+        <p:nvSpPr>
+          <p:cNvPr id="9" name="Text 6"/>
+          <p:cNvSpPr/>
+          <p:nvPr/>
+        </p:nvSpPr>
+        <p:spPr>
+          <a:xfrm>
+            <a:off x="1188720" y="2423160"/>
+            <a:ext cx="3200400" cy="219456"/>
+          </a:xfrm>
+          <a:prstGeom prst="rect">
+            <a:avLst/>
+          </a:prstGeom>
+          <a:noFill/>
+          <a:ln/>
+        </p:spPr>
+        <p:txBody>
+          <a:bodyPr wrap="square" lIns="0" tIns="0" rIns="0" bIns="0" rtlCol="0" anchor="ctr"/>
+          <a:lstStyle/>
+          <a:p>
+            <a:pPr indent="0" marL="0">
+              <a:buNone/>
+            </a:pPr>
+            <a:r>
+              <a:rPr lang="en-US" sz="1000" b="1" spc="200" kern="0" dirty="0">
+                <a:solidFill>
+                  <a:srgbClr val="CC785C"/>
+                </a:solidFill>
+                <a:latin typeface="Calibri" pitchFamily="34" charset="0"/>
+                <a:ea typeface="Calibri" pitchFamily="34" charset="-122"/>
+                <a:cs typeface="Calibri" pitchFamily="34" charset="-120"/>
+              </a:rPr>
+              <a:t>Dropped details</a:t>
+            </a:r>
+            <a:endParaRPr lang="en-US" sz="1000" dirty="0"/>
+          </a:p>
+        </p:txBody>
+      </p:sp>
+      <p:sp>
+        <p:nvSpPr>
+          <p:cNvPr id="10" name="Text 7"/>
+          <p:cNvSpPr/>
+          <p:nvPr/>
+        </p:nvSpPr>
+        <p:spPr>
+          <a:xfrm>
+            <a:off x="758952" y="2697480"/>
+            <a:ext cx="3611880" cy="594360"/>
+          </a:xfrm>
+          <a:prstGeom prst="rect">
+            <a:avLst/>
+          </a:prstGeom>
+          <a:noFill/>
+          <a:ln/>
+        </p:spPr>
+        <p:txBody>
+          <a:bodyPr wrap="square" lIns="0" tIns="0" rIns="0" bIns="0" rtlCol="0" anchor="ctr"/>
+          <a:lstStyle/>
+          <a:p>
+            <a:pPr indent="0" marL="0">
+              <a:buNone/>
+            </a:pPr>
+            <a:r>
+              <a:rPr lang="en-US" sz="1100" dirty="0">
+                <a:solidFill>
+                  <a:srgbClr val="6B6A66"/>
+                </a:solidFill>
+                <a:latin typeface="Calibri" pitchFamily="34" charset="0"/>
+                <a:ea typeface="Calibri" pitchFamily="34" charset="-122"/>
+                <a:cs typeface="Calibri" pitchFamily="34" charset="-120"/>
+              </a:rPr>
+              <a:t>Long sessions and huge files strain the context window; earlier details get dropped. Reset with /clear, trim with /compact, point with @.</a:t>
+            </a:r>
+            <a:endParaRPr lang="en-US" sz="1100" dirty="0"/>
+          </a:p>
+        </p:txBody>
+      </p:sp>
+      <p:sp>
+        <p:nvSpPr>
+          <p:cNvPr id="11" name="Shape 8"/>
+          <p:cNvSpPr/>
+          <p:nvPr/>
+        </p:nvSpPr>
+        <p:spPr>
+          <a:xfrm>
+            <a:off x="4617720" y="1965960"/>
+            <a:ext cx="4023360" cy="1371600"/>
+          </a:xfrm>
+          <a:prstGeom prst="rect">
+            <a:avLst/>
+          </a:prstGeom>
+          <a:solidFill>
+            <a:srgbClr val="FFFFFF"/>
+          </a:solidFill>
+          <a:ln w="9525">
+            <a:solidFill>
+              <a:srgbClr val="E3DFD7"/>
+            </a:solidFill>
+            <a:prstDash val="solid"/>
+          </a:ln>
+          <a:effectLst>
+            <a:outerShdw sx="100000" sy="100000" kx="0" ky="0" algn="bl" rotWithShape="0" blurRad="127000" dist="25400" dir="5400000">
+              <a:srgbClr val="000000">
+                <a:alpha val="8000"/>
+              </a:srgbClr>
+            </a:outerShdw>
+          </a:effectLst>
+        </p:spPr>
+      </p:sp>
+      <p:sp>
+        <p:nvSpPr>
+          <p:cNvPr id="12" name="Shape 9"/>
+          <p:cNvSpPr/>
+          <p:nvPr/>
+        </p:nvSpPr>
+        <p:spPr>
+          <a:xfrm>
+            <a:off x="4617720" y="1965960"/>
+            <a:ext cx="64008" cy="1371600"/>
+          </a:xfrm>
+          <a:prstGeom prst="rect">
+            <a:avLst/>
+          </a:prstGeom>
+          <a:solidFill>
+            <a:srgbClr val="CC785C"/>
+          </a:solidFill>
+          <a:ln w="12700">
+            <a:solidFill>
+              <a:srgbClr val="CC785C"/>
+            </a:solidFill>
+            <a:prstDash val="solid"/>
+          </a:ln>
+        </p:spPr>
+      </p:sp>
+      <p:pic>
+        <p:nvPicPr>
+          <p:cNvPr id="13" name="Image 1" descr="preencoded.png">    </p:cNvPr>
+          <p:cNvPicPr>
+            <a:picLocks noChangeAspect="1"/>
+          </p:cNvPicPr>
+          <p:nvPr/>
+        </p:nvPicPr>
+        <p:blipFill>
+          <a:blip r:embed="rId2"/>
+          <a:stretch>
+            <a:fillRect/>
+          </a:stretch>
+        </p:blipFill>
+        <p:spPr>
+          <a:xfrm>
+            <a:off x="4873752" y="2194560"/>
+            <a:ext cx="320040" cy="320040"/>
+          </a:xfrm>
+          <a:prstGeom prst="rect">
+            <a:avLst/>
+          </a:prstGeom>
+        </p:spPr>
+      </p:pic>
+      <p:sp>
+        <p:nvSpPr>
+          <p:cNvPr id="14" name="Text 10"/>
+          <p:cNvSpPr/>
+          <p:nvPr/>
+        </p:nvSpPr>
+        <p:spPr>
+          <a:xfrm>
+            <a:off x="5303520" y="2130552"/>
+            <a:ext cx="3200400" cy="320040"/>
+          </a:xfrm>
+          <a:prstGeom prst="rect">
+            <a:avLst/>
+          </a:prstGeom>
+          <a:noFill/>
+          <a:ln/>
+        </p:spPr>
+        <p:txBody>
+          <a:bodyPr wrap="square" lIns="0" tIns="0" rIns="0" bIns="0" rtlCol="0" anchor="ctr"/>
+          <a:lstStyle/>
+          <a:p>
+            <a:pPr indent="0" marL="0">
+              <a:buNone/>
+            </a:pPr>
+            <a:r>
+              <a:rPr lang="en-US" sz="1800" b="1" dirty="0">
+                <a:solidFill>
+                  <a:srgbClr val="1A1B1F"/>
+                </a:solidFill>
+                <a:latin typeface="Georgia" pitchFamily="34" charset="0"/>
+                <a:ea typeface="Georgia" pitchFamily="34" charset="-122"/>
+                <a:cs typeface="Georgia" pitchFamily="34" charset="-120"/>
+              </a:rPr>
+              <a:t>Hallucinations</a:t>
+            </a:r>
+            <a:endParaRPr lang="en-US" sz="1800" dirty="0"/>
+          </a:p>
+        </p:txBody>
+      </p:sp>
+      <p:sp>
+        <p:nvSpPr>
+          <p:cNvPr id="15" name="Text 11"/>
+          <p:cNvSpPr/>
+          <p:nvPr/>
+        </p:nvSpPr>
+        <p:spPr>
+          <a:xfrm>
+            <a:off x="5303520" y="2423160"/>
+            <a:ext cx="3200400" cy="219456"/>
+          </a:xfrm>
+          <a:prstGeom prst="rect">
+            <a:avLst/>
+          </a:prstGeom>
+          <a:noFill/>
+          <a:ln/>
+        </p:spPr>
+        <p:txBody>
+          <a:bodyPr wrap="square" lIns="0" tIns="0" rIns="0" bIns="0" rtlCol="0" anchor="ctr"/>
+          <a:lstStyle/>
+          <a:p>
+            <a:pPr indent="0" marL="0">
+              <a:buNone/>
+            </a:pPr>
+            <a:r>
+              <a:rPr lang="en-US" sz="1000" b="1" spc="200" kern="0" dirty="0">
+                <a:solidFill>
+                  <a:srgbClr val="CC785C"/>
+                </a:solidFill>
+                <a:latin typeface="Calibri" pitchFamily="34" charset="0"/>
+                <a:ea typeface="Calibri" pitchFamily="34" charset="-122"/>
+                <a:cs typeface="Calibri" pitchFamily="34" charset="-120"/>
+              </a:rPr>
+              <a:t>Plausible but wrong</a:t>
+            </a:r>
+            <a:endParaRPr lang="en-US" sz="1000" dirty="0"/>
+          </a:p>
+        </p:txBody>
+      </p:sp>
+      <p:sp>
+        <p:nvSpPr>
+          <p:cNvPr id="16" name="Text 12"/>
+          <p:cNvSpPr/>
+          <p:nvPr/>
+        </p:nvSpPr>
+        <p:spPr>
+          <a:xfrm>
+            <a:off x="4873752" y="2697480"/>
+            <a:ext cx="3611880" cy="594360"/>
+          </a:xfrm>
+          <a:prstGeom prst="rect">
+            <a:avLst/>
+          </a:prstGeom>
+          <a:noFill/>
+          <a:ln/>
+        </p:spPr>
+        <p:txBody>
+          <a:bodyPr wrap="square" lIns="0" tIns="0" rIns="0" bIns="0" rtlCol="0" anchor="ctr"/>
+          <a:lstStyle/>
+          <a:p>
+            <a:pPr indent="0" marL="0">
+              <a:buNone/>
+            </a:pPr>
+            <a:r>
+              <a:rPr lang="en-US" sz="1100" dirty="0">
+                <a:solidFill>
+                  <a:srgbClr val="6B6A66"/>
+                </a:solidFill>
+                <a:latin typeface="Calibri" pitchFamily="34" charset="0"/>
+                <a:ea typeface="Calibri" pitchFamily="34" charset="-122"/>
+                <a:cs typeface="Calibri" pitchFamily="34" charset="-120"/>
+              </a:rPr>
+              <a:t>When evidence is thin, Claude still answers assertively. Verify behavior and APIs — not just that the code compiles.</a:t>
+            </a:r>
+            <a:endParaRPr lang="en-US" sz="1100" dirty="0"/>
+          </a:p>
+        </p:txBody>
+      </p:sp>
+      <p:sp>
+        <p:nvSpPr>
+          <p:cNvPr id="17" name="Shape 13"/>
+          <p:cNvSpPr/>
+          <p:nvPr/>
+        </p:nvSpPr>
+        <p:spPr>
+          <a:xfrm>
+            <a:off x="502920" y="3429000"/>
+            <a:ext cx="4023360" cy="1371600"/>
+          </a:xfrm>
+          <a:prstGeom prst="rect">
+            <a:avLst/>
+          </a:prstGeom>
+          <a:solidFill>
+            <a:srgbClr val="FFFFFF"/>
+          </a:solidFill>
+          <a:ln w="9525">
+            <a:solidFill>
+              <a:srgbClr val="E3DFD7"/>
+            </a:solidFill>
+            <a:prstDash val="solid"/>
+          </a:ln>
+          <a:effectLst>
+            <a:outerShdw sx="100000" sy="100000" kx="0" ky="0" algn="bl" rotWithShape="0" blurRad="127000" dist="25400" dir="5400000">
+              <a:srgbClr val="000000">
+                <a:alpha val="8000"/>
+              </a:srgbClr>
+            </a:outerShdw>
+          </a:effectLst>
+        </p:spPr>
+      </p:sp>
+      <p:sp>
+        <p:nvSpPr>
+          <p:cNvPr id="18" name="Shape 14"/>
+          <p:cNvSpPr/>
+          <p:nvPr/>
+        </p:nvSpPr>
+        <p:spPr>
+          <a:xfrm>
+            <a:off x="502920" y="3429000"/>
+            <a:ext cx="64008" cy="1371600"/>
+          </a:xfrm>
+          <a:prstGeom prst="rect">
+            <a:avLst/>
+          </a:prstGeom>
+          <a:solidFill>
+            <a:srgbClr val="CC785C"/>
+          </a:solidFill>
+          <a:ln w="12700">
+            <a:solidFill>
+              <a:srgbClr val="CC785C"/>
+            </a:solidFill>
+            <a:prstDash val="solid"/>
+          </a:ln>
+        </p:spPr>
+      </p:sp>
+      <p:pic>
+        <p:nvPicPr>
+          <p:cNvPr id="19" name="Image 2" descr="preencoded.png">    </p:cNvPr>
+          <p:cNvPicPr>
+            <a:picLocks noChangeAspect="1"/>
+          </p:cNvPicPr>
+          <p:nvPr/>
+        </p:nvPicPr>
+        <p:blipFill>
+          <a:blip r:embed="rId3"/>
+          <a:stretch>
+            <a:fillRect/>
+          </a:stretch>
+        </p:blipFill>
+        <p:spPr>
+          <a:xfrm>
+            <a:off x="758952" y="3657600"/>
+            <a:ext cx="320040" cy="320040"/>
+          </a:xfrm>
+          <a:prstGeom prst="rect">
+            <a:avLst/>
+          </a:prstGeom>
+        </p:spPr>
+      </p:pic>
+      <p:sp>
+        <p:nvSpPr>
+          <p:cNvPr id="20" name="Text 15"/>
+          <p:cNvSpPr/>
+          <p:nvPr/>
+        </p:nvSpPr>
+        <p:spPr>
+          <a:xfrm>
+            <a:off x="1188720" y="3593592"/>
+            <a:ext cx="3200400" cy="320040"/>
+          </a:xfrm>
+          <a:prstGeom prst="rect">
+            <a:avLst/>
+          </a:prstGeom>
+          <a:noFill/>
+          <a:ln/>
+        </p:spPr>
+        <p:txBody>
+          <a:bodyPr wrap="square" lIns="0" tIns="0" rIns="0" bIns="0" rtlCol="0" anchor="ctr"/>
+          <a:lstStyle/>
+          <a:p>
+            <a:pPr indent="0" marL="0">
+              <a:buNone/>
+            </a:pPr>
+            <a:r>
+              <a:rPr lang="en-US" sz="1800" b="1" dirty="0">
+                <a:solidFill>
+                  <a:srgbClr val="1A1B1F"/>
+                </a:solidFill>
+                <a:latin typeface="Georgia" pitchFamily="34" charset="0"/>
+                <a:ea typeface="Georgia" pitchFamily="34" charset="-122"/>
+                <a:cs typeface="Georgia" pitchFamily="34" charset="-120"/>
+              </a:rPr>
+              <a:t>Hidden state</a:t>
+            </a:r>
+            <a:endParaRPr lang="en-US" sz="1800" dirty="0"/>
+          </a:p>
+        </p:txBody>
+      </p:sp>
+      <p:sp>
+        <p:nvSpPr>
+          <p:cNvPr id="21" name="Text 16"/>
+          <p:cNvSpPr/>
+          <p:nvPr/>
+        </p:nvSpPr>
+        <p:spPr>
+          <a:xfrm>
+            <a:off x="1188720" y="3886200"/>
+            <a:ext cx="3200400" cy="219456"/>
+          </a:xfrm>
+          <a:prstGeom prst="rect">
+            <a:avLst/>
+          </a:prstGeom>
+          <a:noFill/>
+          <a:ln/>
+        </p:spPr>
+        <p:txBody>
+          <a:bodyPr wrap="square" lIns="0" tIns="0" rIns="0" bIns="0" rtlCol="0" anchor="ctr"/>
+          <a:lstStyle/>
+          <a:p>
+            <a:pPr indent="0" marL="0">
+              <a:buNone/>
+            </a:pPr>
+            <a:r>
+              <a:rPr lang="en-US" sz="1000" b="1" spc="200" kern="0" dirty="0">
+                <a:solidFill>
+                  <a:srgbClr val="CC785C"/>
+                </a:solidFill>
+                <a:latin typeface="Calibri" pitchFamily="34" charset="0"/>
+                <a:ea typeface="Calibri" pitchFamily="34" charset="-122"/>
+                <a:cs typeface="Calibri" pitchFamily="34" charset="-120"/>
+              </a:rPr>
+              <a:t>Invisible to the code</a:t>
+            </a:r>
+            <a:endParaRPr lang="en-US" sz="1000" dirty="0"/>
+          </a:p>
+        </p:txBody>
+      </p:sp>
+      <p:sp>
+        <p:nvSpPr>
+          <p:cNvPr id="22" name="Text 17"/>
+          <p:cNvSpPr/>
+          <p:nvPr/>
+        </p:nvSpPr>
+        <p:spPr>
+          <a:xfrm>
+            <a:off x="758952" y="4160520"/>
+            <a:ext cx="3611880" cy="594360"/>
+          </a:xfrm>
+          <a:prstGeom prst="rect">
+            <a:avLst/>
+          </a:prstGeom>
+          <a:noFill/>
+          <a:ln/>
+        </p:spPr>
+        <p:txBody>
+          <a:bodyPr wrap="square" lIns="0" tIns="0" rIns="0" bIns="0" rtlCol="0" anchor="ctr"/>
+          <a:lstStyle/>
+          <a:p>
+            <a:pPr indent="0" marL="0">
+              <a:buNone/>
+            </a:pPr>
+            <a:r>
+              <a:rPr lang="en-US" sz="1100" dirty="0">
+                <a:solidFill>
+                  <a:srgbClr val="6B6A66"/>
+                </a:solidFill>
+                <a:latin typeface="Calibri" pitchFamily="34" charset="0"/>
+                <a:ea typeface="Calibri" pitchFamily="34" charset="-122"/>
+                <a:cs typeface="Calibri" pitchFamily="34" charset="-120"/>
+              </a:rPr>
+              <a:t>External APIs, runtime config, feature flags, and team conventions don't live in the code. Point Claude at them explicitly.</a:t>
+            </a:r>
+            <a:endParaRPr lang="en-US" sz="1100" dirty="0"/>
+          </a:p>
+        </p:txBody>
+      </p:sp>
+      <p:sp>
+        <p:nvSpPr>
+          <p:cNvPr id="23" name="Shape 18"/>
+          <p:cNvSpPr/>
+          <p:nvPr/>
+        </p:nvSpPr>
+        <p:spPr>
+          <a:xfrm>
+            <a:off x="4617720" y="3429000"/>
+            <a:ext cx="4023360" cy="1371600"/>
+          </a:xfrm>
+          <a:prstGeom prst="rect">
+            <a:avLst/>
+          </a:prstGeom>
+          <a:solidFill>
+            <a:srgbClr val="FFFFFF"/>
+          </a:solidFill>
+          <a:ln w="9525">
+            <a:solidFill>
+              <a:srgbClr val="E3DFD7"/>
+            </a:solidFill>
+            <a:prstDash val="solid"/>
+          </a:ln>
+          <a:effectLst>
+            <a:outerShdw sx="100000" sy="100000" kx="0" ky="0" algn="bl" rotWithShape="0" blurRad="127000" dist="25400" dir="5400000">
+              <a:srgbClr val="000000">
+                <a:alpha val="8000"/>
+              </a:srgbClr>
+            </a:outerShdw>
+          </a:effectLst>
+        </p:spPr>
+      </p:sp>
+      <p:sp>
+        <p:nvSpPr>
+          <p:cNvPr id="24" name="Shape 19"/>
+          <p:cNvSpPr/>
+          <p:nvPr/>
+        </p:nvSpPr>
+        <p:spPr>
+          <a:xfrm>
+            <a:off x="4617720" y="3429000"/>
+            <a:ext cx="64008" cy="1371600"/>
+          </a:xfrm>
+          <a:prstGeom prst="rect">
+            <a:avLst/>
+          </a:prstGeom>
+          <a:solidFill>
+            <a:srgbClr val="CC785C"/>
+          </a:solidFill>
+          <a:ln w="12700">
+            <a:solidFill>
+              <a:srgbClr val="CC785C"/>
+            </a:solidFill>
+            <a:prstDash val="solid"/>
+          </a:ln>
+        </p:spPr>
+      </p:sp>
+      <p:pic>
+        <p:nvPicPr>
+          <p:cNvPr id="25" name="Image 3" descr="preencoded.png">    </p:cNvPr>
+          <p:cNvPicPr>
+            <a:picLocks noChangeAspect="1"/>
+          </p:cNvPicPr>
+          <p:nvPr/>
+        </p:nvPicPr>
+        <p:blipFill>
+          <a:blip r:embed="rId4"/>
+          <a:stretch>
+            <a:fillRect/>
+          </a:stretch>
+        </p:blipFill>
+        <p:spPr>
+          <a:xfrm>
+            <a:off x="4873752" y="3657600"/>
+            <a:ext cx="320040" cy="320040"/>
+          </a:xfrm>
+          <a:prstGeom prst="rect">
+            <a:avLst/>
+          </a:prstGeom>
+        </p:spPr>
+      </p:pic>
+      <p:sp>
+        <p:nvSpPr>
+          <p:cNvPr id="26" name="Text 20"/>
+          <p:cNvSpPr/>
+          <p:nvPr/>
+        </p:nvSpPr>
+        <p:spPr>
+          <a:xfrm>
+            <a:off x="5303520" y="3593592"/>
+            <a:ext cx="3200400" cy="320040"/>
+          </a:xfrm>
+          <a:prstGeom prst="rect">
+            <a:avLst/>
+          </a:prstGeom>
+          <a:noFill/>
+          <a:ln/>
+        </p:spPr>
+        <p:txBody>
+          <a:bodyPr wrap="square" lIns="0" tIns="0" rIns="0" bIns="0" rtlCol="0" anchor="ctr"/>
+          <a:lstStyle/>
+          <a:p>
+            <a:pPr indent="0" marL="0">
+              <a:buNone/>
+            </a:pPr>
+            <a:r>
+              <a:rPr lang="en-US" sz="1800" b="1" dirty="0">
+                <a:solidFill>
+                  <a:srgbClr val="1A1B1F"/>
+                </a:solidFill>
+                <a:latin typeface="Georgia" pitchFamily="34" charset="0"/>
+                <a:ea typeface="Georgia" pitchFamily="34" charset="-122"/>
+                <a:cs typeface="Georgia" pitchFamily="34" charset="-120"/>
+              </a:rPr>
+              <a:t>Review</a:t>
+            </a:r>
+            <a:endParaRPr lang="en-US" sz="1800" dirty="0"/>
+          </a:p>
+        </p:txBody>
+      </p:sp>
+      <p:sp>
+        <p:nvSpPr>
+          <p:cNvPr id="27" name="Text 21"/>
+          <p:cNvSpPr/>
+          <p:nvPr/>
+        </p:nvSpPr>
+        <p:spPr>
+          <a:xfrm>
+            <a:off x="5303520" y="3886200"/>
+            <a:ext cx="3200400" cy="219456"/>
+          </a:xfrm>
+          <a:prstGeom prst="rect">
+            <a:avLst/>
+          </a:prstGeom>
+          <a:noFill/>
+          <a:ln/>
+        </p:spPr>
+        <p:txBody>
+          <a:bodyPr wrap="square" lIns="0" tIns="0" rIns="0" bIns="0" rtlCol="0" anchor="ctr"/>
+          <a:lstStyle/>
+          <a:p>
+            <a:pPr indent="0" marL="0">
+              <a:buNone/>
+            </a:pPr>
+            <a:r>
+              <a:rPr lang="en-US" sz="1000" b="1" spc="200" kern="0" dirty="0">
+                <a:solidFill>
+                  <a:srgbClr val="CC785C"/>
+                </a:solidFill>
+                <a:latin typeface="Calibri" pitchFamily="34" charset="0"/>
+                <a:ea typeface="Calibri" pitchFamily="34" charset="-122"/>
+                <a:cs typeface="Calibri" pitchFamily="34" charset="-120"/>
+              </a:rPr>
+              <a:t>You own the diff</a:t>
+            </a:r>
+            <a:endParaRPr lang="en-US" sz="1000" dirty="0"/>
+          </a:p>
+        </p:txBody>
+      </p:sp>
+      <p:sp>
+        <p:nvSpPr>
+          <p:cNvPr id="28" name="Text 22"/>
+          <p:cNvSpPr/>
+          <p:nvPr/>
+        </p:nvSpPr>
+        <p:spPr>
+          <a:xfrm>
+            <a:off x="4873752" y="4160520"/>
+            <a:ext cx="3611880" cy="594360"/>
+          </a:xfrm>
+          <a:prstGeom prst="rect">
+            <a:avLst/>
+          </a:prstGeom>
+          <a:noFill/>
+          <a:ln/>
+        </p:spPr>
+        <p:txBody>
+          <a:bodyPr wrap="square" lIns="0" tIns="0" rIns="0" bIns="0" rtlCol="0" anchor="ctr"/>
+          <a:lstStyle/>
+          <a:p>
+            <a:pPr indent="0" marL="0">
+              <a:buNone/>
+            </a:pPr>
+            <a:r>
+              <a:rPr lang="en-US" sz="1100" dirty="0">
+                <a:solidFill>
+                  <a:srgbClr val="6B6A66"/>
+                </a:solidFill>
+                <a:latin typeface="Calibri" pitchFamily="34" charset="0"/>
+                <a:ea typeface="Calibri" pitchFamily="34" charset="-122"/>
+                <a:cs typeface="Calibri" pitchFamily="34" charset="-120"/>
+              </a:rPr>
+              <a:t>Tests can pass on wrong code; commit messages can misstate intent. Read every hunk before merging — Claude is a contributor, not an owner.</a:t>
+            </a:r>
+            <a:endParaRPr lang="en-US" sz="1100" dirty="0"/>
+          </a:p>
+        </p:txBody>
+      </p:sp>
+      <p:sp>
+        <p:nvSpPr>
+          <p:cNvPr id="29" name="Text 23"/>
+          <p:cNvSpPr/>
+          <p:nvPr/>
+        </p:nvSpPr>
+        <p:spPr>
+          <a:xfrm>
+            <a:off x="8321040" y="4709160"/>
+            <a:ext cx="365760" cy="228600"/>
+          </a:xfrm>
+          <a:prstGeom prst="rect">
+            <a:avLst/>
+          </a:prstGeom>
+          <a:noFill/>
+          <a:ln/>
+        </p:spPr>
+        <p:txBody>
+          <a:bodyPr wrap="square" lIns="0" tIns="0" rIns="0" bIns="0" rtlCol="0" anchor="ctr"/>
+          <a:lstStyle/>
+          <a:p>
+            <a:pPr algn="r" indent="0" marL="0">
+              <a:buNone/>
+            </a:pPr>
+            <a:r>
+              <a:rPr lang="en-US" sz="1000" dirty="0">
+                <a:solidFill>
+                  <a:srgbClr val="6B6A66"/>
+                </a:solidFill>
+                <a:latin typeface="Calibri" pitchFamily="34" charset="0"/>
+                <a:ea typeface="Calibri" pitchFamily="34" charset="-122"/>
+                <a:cs typeface="Calibri" pitchFamily="34" charset="-120"/>
+              </a:rPr>
               <a:t>14</a:t>
             </a:r>
             <a:endParaRPr lang="en-US" sz="1000" dirty="0"/>
@@ -7607,7 +8681,7 @@
                 <a:ea typeface="Calibri" pitchFamily="34" charset="-122"/>
                 <a:cs typeface="Calibri" pitchFamily="34" charset="-120"/>
               </a:rPr>
-              <a:t>Claude Code is Anthropic's agentic coding assistant. It understands your codebase and works across files, tools, and terminals — through natural language.</a:t>
+              <a:t>Claude Code is Anthropic's agentic coding assistant. It reads your codebase, reasons over it, and works across files, tools, and terminals — through natural language.</a:t>
             </a:r>
             <a:endParaRPr lang="en-US" sz="1500" dirty="0"/>
           </a:p>
@@ -13695,7 +14769,7 @@
                 <a:ea typeface="Calibri" pitchFamily="34" charset="-122"/>
                 <a:cs typeface="Calibri" pitchFamily="34" charset="-120"/>
               </a:rPr>
-              <a:t>Give each subagent only the tools it needs. A reviewer can't run bash.</a:t>
+              <a:t>Give each subagent only the tools it needs — a reviewer doesn't need Bash.</a:t>
             </a:r>
             <a:endParaRPr lang="en-US" sz="1100" dirty="0"/>
           </a:p>
@@ -14537,7 +15611,7 @@
                 <a:ea typeface="Calibri" pitchFamily="34" charset="-122"/>
                 <a:cs typeface="Calibri" pitchFamily="34" charset="-120"/>
               </a:rPr>
-              <a:t>The work Claude Code takes off your plate — from first commit to production release.</a:t>
+              <a:t>Common categories of work people hand to Claude Code. You review the diff before it lands.</a:t>
             </a:r>
             <a:endParaRPr lang="en-US" sz="1300" dirty="0"/>
           </a:p>
@@ -14696,7 +15770,7 @@
                 <a:ea typeface="Calibri" pitchFamily="34" charset="-122"/>
                 <a:cs typeface="Calibri" pitchFamily="34" charset="-120"/>
               </a:rPr>
-              <a:t>Plans across files, writes code, and verifies it works.</a:t>
+              <a:t>Plans across files, writes code and tests, runs the suite.</a:t>
             </a:r>
             <a:endParaRPr lang="en-US" sz="1100" dirty="0"/>
           </a:p>
@@ -14855,7 +15929,7 @@
                 <a:ea typeface="Calibri" pitchFamily="34" charset="-122"/>
                 <a:cs typeface="Calibri" pitchFamily="34" charset="-120"/>
               </a:rPr>
-              <a:t>Traces errors to root cause and implements the fix.</a:t>
+              <a:t>Reads the stack trace, traces the cause, proposes a patch.</a:t>
             </a:r>
             <a:endParaRPr lang="en-US" sz="1100" dirty="0"/>
           </a:p>
@@ -15014,7 +16088,7 @@
                 <a:ea typeface="Calibri" pitchFamily="34" charset="-122"/>
                 <a:cs typeface="Calibri" pitchFamily="34" charset="-120"/>
               </a:rPr>
-              <a:t>Multi-file refactors at scale — safely and consistently.</a:t>
+              <a:t>Renames, restructures, or extracts across many files at once.</a:t>
             </a:r>
             <a:endParaRPr lang="en-US" sz="1100" dirty="0"/>
           </a:p>
@@ -15173,7 +16247,7 @@
                 <a:ea typeface="Calibri" pitchFamily="34" charset="-122"/>
                 <a:cs typeface="Calibri" pitchFamily="34" charset="-120"/>
               </a:rPr>
-              <a:t>Generates tests, runs the suite, iterates until green.</a:t>
+              <a:t>Generates tests, runs the suite, iterates on failures.</a:t>
             </a:r>
             <a:endParaRPr lang="en-US" sz="1100" dirty="0"/>
           </a:p>
@@ -15332,7 +16406,7 @@
                 <a:ea typeface="Calibri" pitchFamily="34" charset="-122"/>
                 <a:cs typeface="Calibri" pitchFamily="34" charset="-120"/>
               </a:rPr>
-              <a:t>Walks you through unfamiliar systems and dependencies.</a:t>
+              <a:t>Reads an unfamiliar system and walks you through it.</a:t>
             </a:r>
             <a:endParaRPr lang="en-US" sz="1100" dirty="0"/>
           </a:p>
@@ -15491,7 +16565,7 @@
                 <a:ea typeface="Calibri" pitchFamily="34" charset="-122"/>
                 <a:cs typeface="Calibri" pitchFamily="34" charset="-120"/>
               </a:rPr>
-              <a:t>Branches, commits, PRs, merge conflicts — all handled.</a:t>
+              <a:t>Drafts commits, resolves conflicts, opens PRs.</a:t>
             </a:r>
             <a:endParaRPr lang="en-US" sz="1100" dirty="0"/>
           </a:p>

</xml_diff>

<commit_message>
docs: rewrite all speaker notes in presenter voice
Old notes read like AI-written prose — full paragraphs explaining
concepts. Rewritten as cue-card style: descriptive ("here is X" not
"I show X"), short sentences, bullets where useful, no duplication
of on-slide text. Intent: notes read fast while presenting, give
pointers to what to say, not summaries to read aloud.

https://claude.ai/code/session_01Kgzc6V4nJffvzBdXGUme9z
</commit_message>
<xml_diff>
--- a/Claude_Code.pptx
+++ b/Claude_Code.pptx
@@ -516,9 +516,10 @@
           <a:p>
             <a:r>
               <a:rPr lang="en-US" dirty="0"/>
-              <a:t>Deschiderea: ăsta e un brief intern, nu o prezentare de vânzare. Acoperim ce e Claude Code, vocabularul de reținut (MCP, Skills, Subagents), ce face bine și comenzile pe care merită să le ții minte.
-Audiența: engineeri. Scopul e înțelegere comună a vocabularului și capabilităților, nu evangelizare. La final, toată lumea să aibă referințe clare când apare Claude Code într-o discuție tehnică.
-Durata: ~15-20 min cu discuție. Pauze pentru întrebări după slide-urile de concepte (MCP, Skills, Subagents) — alea sunt cele mai dense.</a:t>
+              <a:t>Deschidere. Brief intern, nu vânzare.
+Parcurgem: ce este Claude Code, vocabularul (MCP, Skills, Subagents, CLAUDE.md), ce face bine, unde eșuează, comenzile de bază.
+Audiența e de engineeri. Scopul e înțelegere comună, nu evangelizare.
+Durata: ~15-20 min cu discuție. Pauze după slide-urile de concepte (MCP, Skills, Subagents) — sunt cele mai dense.</a:t>
             </a:r>
             <a:endParaRPr lang="en-US" dirty="0"/>
           </a:p>
@@ -606,14 +607,14 @@
           <a:p>
             <a:r>
               <a:rPr lang="en-US" dirty="0"/>
-              <a:t>Bucla abstractă din slide-ul 3, aplicată pe un task concret — „adaugă rate limiting la API".
-Timing aproximativ în practică:
-• Etapele 1-2 (Understand, Plan) — de obicei secunde, Claude citește câteva fișiere cheie.
-• Etapa 3 (Act) — unde se duce majoritatea timpului. Depinde de mărimea task-ului.
-• Etapa 4 (Verify) — automată când există teste care rulează rapid.
-Dacă planul din etapa 2 nu se aliniază cu ce ai vrut, poți întrerupe cu Ctrl+C și reformula. Nu e necesar să lași bucla să se execute dacă direcția e greșită — devine parte din flow-ul iterativ.
-Procesul e observabil step-by-step — util pentru debugging când ceva iese prost. Dacă verify-ul eșuează, vezi exact la ce etapă și cu ce context a luat decizia greșită.
-Exemplu similar poate fi folosit ca demo live — mic task pe un proiect local.</a:t>
+              <a:t>Bucla din slide 3, aplicată pe un task concret.
+Timing tipic:
+• Understand + Plan — secunde, câteva file reads
+• Act — majoritatea timpului, depinde de scope
+• Verify — automat dacă există teste rapide
+Dacă planul de la etapa 2 nu e bun, Ctrl+C și reformulare. Fără ceremonie.
+Procesul e observabil step-by-step — util pentru debugging când ceva iese prost. Dacă verify eșuează, vezi la ce etapă și cu ce context s-a greșit.
+Demo live posibil aici — task mic pe un proiect local.</a:t>
             </a:r>
             <a:endParaRPr lang="en-US" dirty="0"/>
           </a:p>
@@ -702,15 +703,14 @@
             <a:r>
               <a:rPr lang="en-US" dirty="0"/>
               <a:t>Același agent, interfețe diferite. Alegerea depinde de workflow.
-Orientare pentru echipă:
-• Terminal CLI — toate feature-urile disponibile, comenzi complete.
-• Extensia VS Code — diff viewer integrat, @-mentions în editor.
-• JetBrains — plugin cu funcționalitate similară, pentru IntelliJ, PyCharm, WebStorm.
-• Desktop app — versiune nativă pentru macOS/Windows.
-• Web (claude.ai/code) — rulează în cloud, fără setup local. Util pentru task-uri lungi care pot rula în background.
-• Mobile — apps native iOS (din oct 2025) și Android (din martie 2026). Permite începerea unui task de pe telefon, cu rezultatele accesibile ulterior.
-GitHub Actions e singurul surface non-interactiv — se invocă prin tag-uirea @claude în PR-uri sau issue-uri, util pentru automatizare CI.
-Toate surface-urile împart același cont și configurare — aceleași skills, aceleași MCP servers, aceeași ierarhie CLAUDE.md.</a:t>
+• Terminal CLI — toate feature-urile
+• VS Code — diff viewer integrat, @-mentions
+• JetBrains — plugin similar (IntelliJ, PyCharm, WebStorm)
+• Desktop — macOS/Windows nativ
+• Web (claude.ai/code) — cloud, fără setup local. Bun pentru task-uri lungi în background
+• Mobile — iOS (oct 2025), Android (mar 2026)
+GitHub Actions — singurul non-interactiv. Invocat prin tag `@claude` în PR-uri/issues. Util pentru automatizare.
+Toate împart același cont și configurare: aceleași skills, MCP servers, CLAUDE.md.</a:t>
             </a:r>
             <a:endParaRPr lang="en-US" dirty="0"/>
           </a:p>
@@ -798,13 +798,13 @@
           <a:p>
             <a:r>
               <a:rPr lang="en-US" dirty="0"/>
-              <a:t>Trei prompturi template care acoperă tipologii comune de folosire.
-Ce au în comun: descriu rezultate, nu pași de execuție. Formulare de tipul „deschide fișierul X, modifică linia Y, salvează" e mai puțin eficientă decât formularea la nivel de obiectiv. Claude decide singur pașii pe baza contextului.
-Ordinea în care sunt de încercat (de la cel mai puțin intruziv la cel mai mult):
-1. Understand code — read-only, fără modificări. Util pentru familiarizare cu un proiect necunoscut.
-2. Fix a bug — scope focalizat, verificabil prin teste.
-3. Build a feature — modificări multiple, necesită review atent al diff-ului.
-Notă de prompting: specificitatea constraint-urilor influențează calitatea rezultatului. „Adaugă paginare" e vag. „Adaugă paginare cursor-based la /users cu page size 20, urmând pattern-ul de error-handling din /posts" e specific și produce rezultate mai bine aliniate cu proiectul.</a:t>
+              <a:t>Trei tipologii frecvente.
+Ce au în comun prompturile de pe slide: descriu rezultate + constraint-uri specifice (fișiere, pattern-uri, erori concrete). Nu descriu pași de execuție.
+Ordinea de încercat (ascendent în risc):
+1. Understand — read-only, zero risk
+2. Fix bug — scope focalizat, verificabil prin teste
+3. Build feature — modificări multiple, review atent al diff-ului
+Regula de prompting e vizibilă în exemple: referință la cod existent și la pattern-uri deja în proiect. „Adaugă paginare" e vag. Exemplele de pe slide sunt specifice — de asta funcționează.</a:t>
             </a:r>
             <a:endParaRPr lang="en-US" dirty="0"/>
           </a:p>
@@ -892,17 +892,17 @@
           <a:p>
             <a:r>
               <a:rPr lang="en-US" dirty="0"/>
-              <a:t>Slide-ul ăsta e pentru referință. Nu e necesar de parcurs comandă cu comandă în prezentare — e util post-sesiune.
-Cele două care apar cel mai des în folosirea zilnică:
-• /clear — resetare a istoricului conversației când se trece la un task nou. Previne aglomerarea context-ului cu informații din task-uri anterioare.
-• Shift+Tab — ciclează prin permission modes (Normal → Auto-Accept → Plan). Util când vrei Plan Mode înainte de execuție.
-Alte comenzi utile:
-• /compact — rezumă history-ul păstrând firul conversației. Alternativă la /clear când vrei să păstrezi contextul.
-• `claude -p "..."` — mod non-interactiv. Rulează un prompt, afișează răspunsul, iese. Folosit în shell scripts și pipeline-uri CI.
-• `--permission-mode acceptEdits` — auto-aprobă modificările de fișiere. Util după ce workflow-ul e familiar.
-• `@` — referință la un fișier în prompt, ex: „explică @src/auth.ts".
-• `/memory` — vizualizează și editează memoria auto-salvată între sesiuni (v2.1.59+).
-Notă: Claude Code funcționează fără să memorezi aceste comenzi. Sunt shortcut-uri pentru folosire frecventă.</a:t>
+              <a:t>Slide de referință. Nu de parcurs comandă cu comandă — util post-sesiune.
+Cele două folosite zilnic:
+• /clear — reset când se trece la task nou
+• Shift+Tab — ciclează prin permission modes (Normal → Auto-Accept → Plan)
+Restul, când devin relevante:
+• /compact — rezumă history, păstrează firul
+• /memory — vede și editează memoria auto-salvată
+• `claude -p "..."` — non-interactiv, pentru scripts și CI
+• `--permission-mode acceptEdits` — auto-aprobă modificări de fișiere
+• `@file` — referință la un fișier în prompt (ex: „explică @src/auth.ts")
+Plain English funcționează singur. Astea sunt shortcut-uri pentru folosire frecventă.</a:t>
             </a:r>
             <a:endParaRPr lang="en-US" dirty="0"/>
           </a:p>
@@ -990,15 +990,16 @@
           <a:p>
             <a:r>
               <a:rPr lang="en-US" dirty="0"/>
-              <a:t>Pași concreți de încheiere:
-1. Instalarea Claude Code (instrucțiuni pe docs.claude.com).
-2. Scrierea unui CLAUDE.md pentru proiectul principal — convenții, comenzi uzuale, pattern-uri de urmărit.
-3. Încercarea unui task concret: explicarea unui modul, fix la un bug, sau adăugarea unui test.
-Pentru echipă (discuție ulterioară):
-1. Identificarea MCP servers care s-ar potrivi cu workflow-ul nostru (ex: GitHub, Jira).
-2. Discutarea experienței pe canalul de echipă.
-3. Identificarea pattern-urilor repetitive care ar putea deveni Skills partajate.
-Resurse oficiale: docs.claude.com/en/docs/claude-code. Changelog: docs.claude.com/en/release-notes/claude-code. Exemple de skills în repo-ul public anthropics/skills.
+              <a:t>Închidere + discuție.
+Pași pentru cineva care începe azi:
+1. Instalare (docs.claude.com)
+2. Scrierea unui CLAUDE.md pentru proiectul principal — convenții, comenzi uzuale, pattern-uri
+3. Un task concret: explicare modul, fix la un bug, sau adăugare test
+Pentru echipă (follow-up):
+• Ce MCP servers se potrivesc cu workflow-ul nostru (GitHub, Jira)
+• Unde discutăm experiența (canal dedicat?)
+• Ce pattern-uri repetitive ar putea deveni Skills partajate
+Resurse oficiale: docs.claude.com/en/docs/claude-code. Changelog: /en/release-notes/claude-code. Exemple de skills: github.com/anthropics/skills.
 Întrebări.</a:t>
             </a:r>
             <a:endParaRPr lang="en-US" dirty="0"/>
@@ -1087,12 +1088,12 @@
           <a:p>
             <a:r>
               <a:rPr lang="en-US" dirty="0"/>
-              <a:t>Acest slide e pentru onestitate și pentru a pregăti audiența să recunoască aceste tipare în practică. Niciuna dintre limitări nu e blocantă; toate sunt gestionabile cu review atent.
-• Context dropped: apare la sesiuni lungi, fișiere mari, sau zeci de tool calls. Claude poate să uite o decizie luată la începutul sesiunii. /clear resetează, /compact rezumă, @ aduce conținut la zi în context.
-• Plausible but wrong: cel mai insidios tip de eșec — codul compilează, testele trec, sintaxa e ok, dar comportamentul e greșit. Apare când API-ul real diferă de ce Claude presupune. Verifică cu documentația oficială sau rulări concrete, nu doar cu lint.
-• Hidden state: orice nu e în cod e invizibil pentru Claude — variabile de mediu, feature flags, convenții ne-scrise, comportamentul unui API extern. Dacă task-ul depinde de așa ceva, spune-i explicit: „backend-ul așteaptă camelCase” sau „feature flag X e on în prod”.
-• Own the diff: regula de bază. Claude e un contributor, nu un owner. Citește fiecare hunk ca și cum ar veni de la un coleg nou: nu presupune că înțelege convențiile proiectului la fel de bine ca tine. Green CI nu înseamnă corect.
-Mențiune: nu sunt toate limitările — doar cele mai des întâlnite în munca zilnică. Altele (matematică, rază de acțiune, latență) sunt contextuale și merită discutate separat.</a:t>
+              <a:t>Slide de onestitate. Niciuna dintre limitări nu e blocantă; toate sunt gestionabile cu review atent.
+Context dropped — sesiuni lungi, fișiere mari, zeci de tool calls. Claude poate uita o decizie luată la început. Mitigare: /clear, /compact, @file.
+Plausible but wrong — cel mai insidios. Codul compilează, testele trec, dar comportamentul e greșit. Apare când API-ul real diferă de ce presupune. Mitigare: docs oficiale + rulări concrete, nu doar lint.
+Hidden state — variabile de mediu, feature flags, convenții ne-scrise, API-uri externe. Dacă task-ul depinde de ele, le spui explicit: „backend-ul așteaptă camelCase", „feature flag X e on în prod".
+Own the diff — regula de bază. Claude e contributor, nu owner. Read each hunk. Green CI ≠ corect.
+Alte limitări (matematică, rază, latență) sunt contextuale. Menționate la întrebări, dacă apar.</a:t>
             </a:r>
             <a:endParaRPr lang="en-US" dirty="0"/>
           </a:p>
@@ -1180,10 +1181,9 @@
           <a:p>
             <a:r>
               <a:rPr lang="en-US" dirty="0"/>
-              <a:t>Claude Code e tool-ul de coding agentic al Anthropic, lansat în 2025.
-Ideea centrală: descrii un obiectiv în limba normală, Claude citește context-ul relevant din proiect, face un plan, editează fișiere, rulează comenzi (inclusiv teste), iterează dacă ceva nu merge, și îți prezintă rezultatul pentru review.
-Terminal-ul din dreapta e un flow real cu un singur prompt: o cerere („adaugă paginare"), mai multe modificări de fișiere, test run, rezultat gata pentru commit. Round-trip-ul ăsta complet — de la intenție la schimbare verificată — e ce descriem prin „agentic" (detaliat pe slide-ul următor).
-Notă tehnică: binarul CLI se cheamă literalmente `claude`. Produsul e numit după model.</a:t>
+              <a:t>Aici este un loop complet, de la prompt la diff verificat.
+Pe terminalul din dreapta: un singur prompt („adaugă paginare"), fișiere modificate, teste rulate, gata pentru commit. Ăsta e round-trip-ul — intenție → schimbare verificată. Asta înseamnă „agentic" (detalii pe slide 3).
+Binarul se cheamă `claude`. Produsul poartă numele modelului.</a:t>
             </a:r>
             <a:endParaRPr lang="en-US" dirty="0"/>
           </a:p>
@@ -1271,9 +1271,9 @@
           <a:p>
             <a:r>
               <a:rPr lang="en-US" dirty="0"/>
-              <a:t>„Agentic" înseamnă un sistem cu un scop, acces la tool-uri, și autonomia să continue până termină task-ul sau cere input.
-Cele patru etape (Understand → Plan → Act → Verify) sunt un model mental simplificat, nu o taxonomie oficială din docs. Pentru task-uri complexe, bucla se execută de mai multe ori — Claude încearcă ceva, realizează că-i lipsește context, mai citește fișiere, re-planifică, acționează din nou.
-Claude cere permisiune înainte de acțiuni semnificative (rulare comenzi, editări de fișiere). Autonomia e limitată prin permisiuni — tu rămâi la butoane.</a:t>
+              <a:t>Definiția simplă: agent = scop + tool-uri + autonomie să itereze.
+Cele patru etape (Understand → Plan → Act → Verify) sunt un model mental, nu taxonomie oficială. Pe task-uri reale, bucla se execută de mai multe ori — încearcă, vede că-i lipsește context, mai citește, re-planifică.
+Permisiunile limitează autonomia: cere aprobare înainte de acțiuni semnificative (rulare comenzi, editări). Tu rămâi la butoane.</a:t>
             </a:r>
             <a:endParaRPr lang="en-US" dirty="0"/>
           </a:p>
@@ -1361,13 +1361,13 @@
           <a:p>
             <a:r>
               <a:rPr lang="en-US" dirty="0"/>
-              <a:t>Aceste patru nume apar constant în documentația Claude Code. Slide-ul ăsta e glosarul — următoarele slide-uri le aprofundează pe fiecare.
-Ordinea în care le vei întâlni:
-• CLAUDE.md — din prima sesiune. E mecanismul prin care proiectul își transmite contextul la Claude.
-• MCP — când vrei ca Claude să acceseze sisteme externe (ticket-uri, documente, baze de date).
-• Skills — când începi să observi pattern-uri repetitive în ce îi ceri.
-• Subagents — cazuri avansate, când vrei să izolezi un task mare de contextul principal.
-Prioritate practică: CLAUDE.md e primul pe care merită să-l configurezi.</a:t>
+              <a:t>Glosar. Următoarele slide-uri detaliază fiecare concept.
+Ordinea în care apar în practică:
+• CLAUDE.md — din prima sesiune
+• MCP — când vrei acces la sisteme externe
+• Skills — când apar pattern-uri repetitive
+• Subagents — avansat, pentru izolat task-uri mari
+Prioritate: CLAUDE.md e primul de configurat într-un repo.</a:t>
             </a:r>
             <a:endParaRPr lang="en-US" dirty="0"/>
           </a:p>
@@ -1455,22 +1455,15 @@
           <a:p>
             <a:r>
               <a:rPr lang="en-US" dirty="0"/>
-              <a:t>Slide-ul ăsta e referință pentru unde trăiește configurarea.
-Puncte de acoperit:
-1. CLAUDE.md e fișierul principal de configurare. Se pune în root-ul repo-ului, se face commit, și Claude îl citește la fiecare sesiune. Docs-urile recomandă sub 200 de linii — fișierele mai lungi reduc cât de consistent le urmează Claude.
-2. Ierarhia CLAUDE.md are trei niveluri:
-   • ~/.claude/CLAUDE.md (global, aplicat peste toate proiectele)
-   • CLAUDE.md (proiect, în repo, partajat cu echipa)
-   • CLAUDE.local.md (personal, gitignored)
-Claude încarcă toate trei și le concatenează. Când există conflicte, tier-ul mai specific (local &gt; project &gt; global) câștigă.
-3. AGENTS.md: Claude Code nu citește direct AGENTS.md. Dacă repo-ul are deja un AGENTS.md (folosit de alte tool-uri AI), poți pune `@AGENTS.md` la începutul CLAUDE.md și conținutul va fi inclus.
-4. Folder-ul .claude/ conține restul configurării:
-   • skills/ — Skills custom (detaliate pe slide-ul următor)
-   • agents/ — definiții de subagents
-   • rules/ — reguli modulare cu scope pe path
-   • settings.json — permisiuni, hooks, configurare MCP servers
-5. Auto memory (v2.1.59+): Claude salvează și singur note între sesiuni, separat de CLAUDE.md manual. Vizualizare cu /memory.
-Comanda `/init` rulată în proiect generează un CLAUDE.md de bază pe care îl poți edita.</a:t>
+              <a:t>Slide de referință. Nu de parcurs în detaliu — e pentru când cineva întreabă „unde pun X".
+CLAUDE.md — rădăcina repo-ului, commit-at, auto-încărcat la fiecare sesiune. Docs recomandă sub 200 de linii — peste, e urmărit mai puțin consistent.
+Ierarhia (se concatenează, tier mai specific câștigă):
+1. ~/.claude/CLAUDE.md — global
+2. CLAUDE.md — proiect
+3. CLAUDE.local.md — personal, gitignored
+AGENTS.md nu e citit direct. Dacă există, se importă cu `@AGENTS.md` în CLAUDE.md.
+.claude/ conține skills/, agents/, rules/, settings.json. Auto memory (v2.1.59+) e accesibilă prin /memory.
+Comanda `/init` generează un CLAUDE.md de bază.</a:t>
             </a:r>
             <a:endParaRPr lang="en-US" dirty="0"/>
           </a:p>
@@ -1558,11 +1551,11 @@
           <a:p>
             <a:r>
               <a:rPr lang="en-US" dirty="0"/>
-              <a:t>MCP e un standard deschis. Nu e specific Anthropic — alte tool-uri AI (Cursor, tool-urile OpenAI, etc.) îl suportă și ele. Un server MCP definit o dată poate fi folosit de mai multe clienți.
-Cum funcționează: un server MCP expune un set de tool-uri și acces la date pentru un sistem extern. Claude se conectează la el și poate invoca tool-urile acelea în timpul sesiunii.
-Cele patru exemple de pe slide (Drive, Slack, Jira, Postgres) sunt servere disponibile public. Mai există multe altele: GitHub, Notion, Linear, Sentry, Datadog, AWS, Google Calendar. Registry-ul MCP public conține lista completă.
-Model de permisiuni: Claude cere aprobare prima dată când folosește un tool MCP într-o sesiune. Aprobarea e reținută pentru restul sesiunii.
-Pentru utilizarea inițială: serverele de GitHub sau Jira sunt exemple de conectori care dau valoare imediată — interogări de tipul „listează PR-urile deschise" sau „ce ticket-uri sunt asignate mie".</a:t>
+              <a:t>MCP e standard deschis — nu specific Anthropic. Cursor, OpenAI și altele îl suportă. Un server definit o dată, folosit de mai mulți clienți.
+Server-ul expune tool-uri + acces la date dintr-un sistem extern. Claude le invocă în sesiune.
+Servere publice relevante: GitHub, Jira, Notion, Linear, Sentry, Datadog, AWS, Postgres. Registry oficial cu lista completă.
+Permisiuni: prima folosire într-o sesiune cere aprobare, restul rulează pe aceeași aprobare.
+Primul experiment util: GitHub sau Jira — câștig imediat („listează PR-urile mele", „ce ticket-uri am").</a:t>
             </a:r>
             <a:endParaRPr lang="en-US" dirty="0"/>
           </a:p>
@@ -1650,15 +1643,17 @@
           <a:p>
             <a:r>
               <a:rPr lang="en-US" dirty="0"/>
-              <a:t>Skills au fost introduse la finalul lui 2025 ca standard deschis (spec-ul „Agent Skills"). Funcționează peste mai multe produse: Claude.ai, Claude Code, API-ul Anthropic.
-Mecanismul de invocare e automat. Claude citește descrierile tuturor skill-urilor instalate la startul sesiunii. Când prompt-ul user-ului se potrivește cu o descriere, Claude încarcă conținutul complet al skill-ului și îl urmează ca instrucțiuni. Câmpul description din YAML frontmatter determină match-ul, deci formularea lui contează.
-Skills sunt utile pentru a codifica proceduri pe care echipa le folosește recurent. Exemple:
-• Checklist de creare PR în formatul convenit
-• Procedura de deployment pentru un serviciu specific
+              <a:t>Skills — spec deschis „Agent Skills", finalul lui 2025. Funcționează peste Claude.ai, Claude Code, API.
+Invocare automată: Claude citește descrierile la start, încarcă skill-ul când prompt-ul se potrivește cu description-ul. Formularea description-ului contează.
+Utile pentru proceduri recurente:
+• Checklist de creare PR
+• Procedura de deploy pentru un serviciu
 • Reguli de security review
-• Pattern-uri de scriere a testelor
-Diferența față de CLAUDE.md: CLAUDE.md e încărcat la fiecare sesiune (context permanent). Skills se încarcă on-demand, doar când sunt relevante. Pentru context care e mereu aplicabil — CLAUDE.md. Pentru proceduri care apar situațional — Skills.
-Locații: `.claude/skills/` (per proiect, în repo, partajat cu echipa) sau `~/.claude/skills/` (personal, peste toate proiectele).</a:t>
+• Pattern de scriere teste
+Diferența față de CLAUDE.md:
+• CLAUDE.md — context permanent, fiecare sesiune
+• Skills — on-demand, doar când sunt relevante
+Locații: `.claude/skills/` (proiect, partajat) sau `~/.claude/skills/` (personal).</a:t>
             </a:r>
             <a:endParaRPr lang="en-US" dirty="0"/>
           </a:p>
@@ -1746,15 +1741,15 @@
           <a:p>
             <a:r>
               <a:rPr lang="en-US" dirty="0"/>
-              <a:t>Subagents rezolvă o problemă specifică: izolarea contextului. Când ai un task care produce mult output intermediar (review-uri, căutări, explorare de cod), acel output ar umple thread-ul principal. Un subagent e o instanță Claude separată, cu propriul context window și propriile tool-uri.
-Exemplu tipic: pentru un security review, delegi task-ul unui subagent. Acesta explorează codul, identifică probleme, și returnează doar un sumar. Thread-ul tău principal nu e poluat cu zecile de file reads pe care subagentul le-a făcut.
-Built-in subagents (documentate în docs oficial):
-• Explore — pentru căutare și analiză read-only de codebase
-• Plan — folosit în Plan Mode pentru culegerea de context
-• general-purpose — pentru task-uri care necesită și explorare, și modificare
-Custom subagents: definiți ca fișiere markdown cu YAML frontmatter în `.claude/agents/`. Câmpul `allowed-tools` restrânge ce poate folosi fiecare subagent (ex: un reviewer nu are acces la Bash, doar la Read/Grep).
-Paralelism: subagents pot rula concurent. Când rulează mai mulți simultan, output-urile lor sunt coordonate de agentul principal.
-Pentru echipa noastră: subagents sunt utile după ce workflow-ul de bază e stabilit. Recomandabil să ne obișnuim întâi cu CLAUDE.md, MCP și prompting-ul direct.</a:t>
+              <a:t>Problema rezolvată: izolarea contextului. Task-uri cu mult output intermediar (review, explorare, căutări) ar umple thread-ul principal. Un subagent rulează separat, returnează doar sumarul.
+Exemplu tipic: security review. Subagentul explorează codul, identifică probleme, răspunde cu un sumar. Thread-ul rămâne curat.
+Built-in:
+• Explore — căutare read-only
+• Plan — cules context în Plan Mode
+• general-purpose — explorare + modificare
+Custom: markdown cu YAML frontmatter în `.claude/agents/`. Câmpul `allowed-tools` restrânge tool-urile per agent.
+Paralelism: pot rula mai mulți simultan, coordonați de agentul principal.
+Ordinea practică de adoptare: CLAUDE.md → MCP → prompting bun → Skills → Subagents. Ultimele două sunt avansate.</a:t>
             </a:r>
             <a:endParaRPr lang="en-US" dirty="0"/>
           </a:p>
@@ -1842,15 +1837,14 @@
           <a:p>
             <a:r>
               <a:rPr lang="en-US" dirty="0"/>
-              <a:t>Slide-ul listează cele șase categorii de acțiuni pentru care Claude Code e folosit cel mai des. Fiecare poate avea un demo de sine stătător.
-Categorii de risc (util pentru echipa care începe):
-Risc minim, bune ca prim contact:
-• Explain code — operații read-only. Util când vrei să înțelegi un modul nou.
-• Fix bugs — scope focalizat, ușor de verificat prin teste.
-Risc mai mare, atenție la review:
-• Refactor — modificări care pot atinge multe fișiere. Diff-ul trebuie citit cu atenție.
-• Operații Git — verifică mesajul de commit și ce e în staging înainte să lași comanda să ruleze.
-Lucrul peste mai multe fișiere e util în particular pentru refactoruri și schimbări consistente — un exemplu: redenumirea unui concept peste tot în codebase.</a:t>
+              <a:t>Categorii frecvente. Fiecare poate avea demo separat dacă întreabă cineva.
+Risc mic (bune ca prim contact):
+• Explain code — read-only
+• Fix bugs — scope focalizat, verificabil
+Risc mare (review atent):
+• Refactor — poate atinge zeci de fișiere
+• Git ops — verifică staged și mesajul de commit înainte să lași comanda să ruleze
+Refactor-ul multi-file e unde valoarea e cea mai vizibilă — ex: redenumirea unui concept consistent în tot codebase-ul.</a:t>
             </a:r>
             <a:endParaRPr lang="en-US" dirty="0"/>
           </a:p>

</xml_diff>